<commit_message>
Translate OneSlide repository content to English
</commit_message>
<xml_diff>
--- a/builder/assets/reference-pages/box-plot-jitter.pptx
+++ b/builder/assets/reference-pages/box-plot-jitter.pptx
@@ -1099,7 +1099,7 @@
                   <a:srgbClr val="15375F"/>
                 </a:solidFill>
               </a:rPr>
-              <a:t>四个班组的典型处理时长接近，但甲组和丁组各有一个明显高值</a:t>
+              <a:t>The typical processing times of the four teams are similar, but Group A and Group D each have a significantly higher value.</a:t>
             </a:r>
           </a:p>
         </p:txBody>
@@ -1151,7 +1151,7 @@
                   <a:srgbClr val="697386"/>
                 </a:solidFill>
               </a:rPr>
-              <a:t>2026年第二季度；每位一线员工月均处理时长；合成示例数据，非真实客户数据</a:t>
+              <a:t>2026Second quarter of the year; average monthly processing time per front-line employee; synthetic sample data, not real customer data</a:t>
             </a:r>
           </a:p>
         </p:txBody>
@@ -1651,7 +1651,7 @@
                   <a:srgbClr val="15375F"/>
                 </a:solidFill>
               </a:rPr>
-              <a:t>分钟</a:t>
+              <a:t>minutes</a:t>
             </a:r>
           </a:p>
         </p:txBody>
@@ -1703,7 +1703,7 @@
                   <a:srgbClr val="697386"/>
                 </a:solidFill>
               </a:rPr>
-              <a:t>样本：在岗满60天且当季有效工单不少于30件的员工</a:t>
+              <a:t>Sample: full on post60days and the valid work orders for the current quarter are no less than30employees</a:t>
             </a:r>
           </a:p>
         </p:txBody>
@@ -2308,7 +2308,7 @@
                   <a:srgbClr val="15375F"/>
                 </a:solidFill>
               </a:rPr>
-              <a:t>甲组</a:t>
+              <a:t>Group A</a:t>
             </a:r>
           </a:p>
         </p:txBody>
@@ -2965,7 +2965,7 @@
                   <a:srgbClr val="15375F"/>
                 </a:solidFill>
               </a:rPr>
-              <a:t>乙组</a:t>
+              <a:t>Group B</a:t>
             </a:r>
           </a:p>
         </p:txBody>
@@ -3622,7 +3622,7 @@
                   <a:srgbClr val="15375F"/>
                 </a:solidFill>
               </a:rPr>
-              <a:t>丙组</a:t>
+              <a:t>Group C</a:t>
             </a:r>
           </a:p>
         </p:txBody>
@@ -4279,7 +4279,7 @@
                   <a:srgbClr val="15375F"/>
                 </a:solidFill>
               </a:rPr>
-              <a:t>丁组</a:t>
+              <a:t>Group D</a:t>
             </a:r>
           </a:p>
         </p:txBody>
@@ -4383,7 +4383,7 @@
                   <a:srgbClr val="697386"/>
                 </a:solidFill>
               </a:rPr>
-              <a:t>箱体：Q1–Q3；中线：中位数；须：1.5×IQR内最远观测；异常值单独标记</a:t>
+              <a:t>Cabinet:Q1–Q3;Midline: median; Must:1.5×IQRthe most distant observation within; outliers are marked individually</a:t>
             </a:r>
           </a:p>
         </p:txBody>
@@ -4435,14 +4435,14 @@
                   <a:srgbClr val="E8872D"/>
                 </a:solidFill>
               </a:rPr>
-              <a:t>横向抖动仅为避免遮挡，不改变观测值</a:t>
+              <a:t>Lateral jitter is only to avoid occlusion and does not change the observation value</a:t>
             </a:r>
           </a:p>
         </p:txBody>
       </p:sp>
       <p:sp>
         <p:nvSpPr>
-          <p:cNvPr id="94" name="关键洞察-rail">
+          <p:cNvPr id="94" name="key insights-rail">
             <a:extLst xmlns:a="http://schemas.openxmlformats.org/drawingml/2006/main">
               <a:ext uri="{FF2B5EF4-FFF2-40B4-BE49-F238E27FC236}">
                 <a16:creationId xmlns:a16="http://schemas.microsoft.com/office/drawing/2014/main" id="{C332A104-E7C4-47E2-A8AB-07D6FD210E54}"/>
@@ -4475,7 +4475,7 @@
       </p:sp>
       <p:sp>
         <p:nvSpPr>
-          <p:cNvPr id="95" name="关键洞察-title">
+          <p:cNvPr id="95" name="key insights-title">
             <a:extLst xmlns:a="http://schemas.openxmlformats.org/drawingml/2006/main">
               <a:ext uri="{FF2B5EF4-FFF2-40B4-BE49-F238E27FC236}">
                 <a16:creationId xmlns:a16="http://schemas.microsoft.com/office/drawing/2014/main" id="{F35D6C62-6089-4084-9A14-01B4B5AC23C3}"/>
@@ -4520,14 +4520,14 @@
                   <a:srgbClr val="15375F"/>
                 </a:solidFill>
               </a:rPr>
-              <a:t>关键洞察</a:t>
+              <a:t>key insights</a:t>
             </a:r>
           </a:p>
         </p:txBody>
       </p:sp>
       <p:sp>
         <p:nvSpPr>
-          <p:cNvPr id="96" name="关键洞察-item-1">
+          <p:cNvPr id="96" name="key insights-item-1">
             <a:extLst xmlns:a="http://schemas.openxmlformats.org/drawingml/2006/main">
               <a:ext uri="{FF2B5EF4-FFF2-40B4-BE49-F238E27FC236}">
                 <a16:creationId xmlns:a16="http://schemas.microsoft.com/office/drawing/2014/main" id="{A8D7B8EA-D2D9-4BD8-A580-E7C557372453}"/>
@@ -4576,14 +4576,14 @@
                   <a:srgbClr val="172033"/>
                 </a:solidFill>
               </a:rPr>
-              <a:t>甲组与丁组分别出现72分钟和65分钟的高值观测，需核对具体工单情境</a:t>
+              <a:t>Group A and Group D appear separately72minutes and65Minutes of high-value observation, need to check the specific work order situation</a:t>
             </a:r>
           </a:p>
         </p:txBody>
       </p:sp>
       <p:sp>
         <p:nvSpPr>
-          <p:cNvPr id="97" name="关键洞察-item-2">
+          <p:cNvPr id="97" name="key insights-item-2">
             <a:extLst xmlns:a="http://schemas.openxmlformats.org/drawingml/2006/main">
               <a:ext uri="{FF2B5EF4-FFF2-40B4-BE49-F238E27FC236}">
                 <a16:creationId xmlns:a16="http://schemas.microsoft.com/office/drawing/2014/main" id="{4CAB0FFD-BB77-499D-9350-A8A296563924}"/>
@@ -4632,7 +4632,7 @@
                   <a:srgbClr val="172033"/>
                 </a:solidFill>
               </a:rPr>
-              <a:t>乙组的观测更集中，组内波动小于甲组与丁组</a:t>
+              <a:t>The observations in Group B are more concentrated, and the fluctuations within the group are smaller than those in Groups A and D.</a:t>
             </a:r>
           </a:p>
         </p:txBody>
@@ -4688,7 +4688,7 @@
                   <a:srgbClr val="15375F"/>
                 </a:solidFill>
               </a:rPr>
-              <a:t>先复核甲组与丁组的高值观测，再判断是否需要调整流程</a:t>
+              <a:t>First review the high-value observations in Group A and Group D, and then determine whether the process needs to be adjusted.</a:t>
             </a:r>
           </a:p>
         </p:txBody>

</xml_diff>